<commit_message>
feat: repo bilingue (ES/EN) + infografias para alumnos
- Documentacion completa traducida al ingles (.en.md) con selector de idioma en cada doc
- 28 archivos .en.md + switcher en los 28 originales en espanol
- Slides del instructor ahora BILINGUES: 8 decks (4 ES + 4 EN) desde una sola fuente (tr)
- NUEVO: infografias para alumnos, 14 laminas de referencia x idioma
  (Infografias_Alumnos_ES.pptx + Student_Infographics_EN.pptx)
- slides/lib.js compartido; generate.js e infographics.js bilingues
- READMEs (ES/EN) actualizados: seccion bilingue + material para alumnos
- QA visual de las 36 slides nuevas: layout limpio, 3 comentarios ES corregidos
</commit_message>
<xml_diff>
--- a/slides/01_Dia_1_DevOps_Docker.pptx
+++ b/slides/01_Dia_1_DevOps_Docker.pptx
@@ -3644,7 +3644,7 @@
                 <a:ea typeface="Calibri" pitchFamily="34" charset="-122"/>
                 <a:cs typeface="Calibri" pitchFamily="34" charset="-120"/>
               </a:rPr>
-              <a:t>ENV DB_PASSWORD=... (quemado)</a:t>
+              <a:t>ENV DB_PASSWORD=... </a:t>
             </a:r>
             <a:endParaRPr lang="en-US" sz="1250" dirty="0"/>
           </a:p>
@@ -3792,7 +3792,7 @@
                 <a:ea typeface="Calibri" pitchFamily="34" charset="-122"/>
                 <a:cs typeface="Calibri" pitchFamily="34" charset="-120"/>
               </a:rPr>
-              <a:t>node:22-alpine (ligera)</a:t>
+              <a:t>node:22-alpine</a:t>
             </a:r>
             <a:endParaRPr lang="en-US" sz="1250" dirty="0"/>
           </a:p>

</xml_diff>